<commit_message>
Restore missing step 2 on Pages setup screenshot
</commit_message>
<xml_diff>
--- a/docs/shift-register-quickstart/lesson-revised.pptx
+++ b/docs/shift-register-quickstart/lesson-revised.pptx
@@ -22463,7 +22463,7 @@
       </p:sp>
       <p:pic>
         <p:nvPicPr>
-          <p:cNvPr id="15" name="Picture 14" descr="pages-source-detail.png"/>
+          <p:cNvPr id="15" name="Picture 14" descr="pages-numbered.png"/>
           <p:cNvPicPr>
             <a:picLocks noChangeAspect="1"/>
           </p:cNvPicPr>
@@ -22477,8 +22477,8 @@
         </p:blipFill>
         <p:spPr>
           <a:xfrm>
-            <a:off x="5760720" y="2606040"/>
-            <a:ext cx="5852160" cy="1618210"/>
+            <a:off x="6205866" y="2606040"/>
+            <a:ext cx="4961866" cy="2322576"/>
           </a:xfrm>
           <a:prstGeom prst="rect">
             <a:avLst/>
@@ -22493,7 +22493,7 @@
         </p:nvSpPr>
         <p:spPr>
           <a:xfrm>
-            <a:off x="5760720" y="4333978"/>
+            <a:off x="5760720" y="5038344"/>
             <a:ext cx="5852160" cy="493776"/>
           </a:xfrm>
           <a:prstGeom prst="rect">
@@ -22519,7 +22519,7 @@
               </a:defRPr>
             </a:pPr>
             <a:r>
-              <a:t>Enlarged detail. Official Tiny Tapeout FAQ image: Source is set to GitHub Actions. Its example repository name may differ from yours.</a:t>
+              <a:t>1 Settings → 2 Pages → 3 GitHub Actions. Official FAQ screenshot; step 2 annotation added.</a:t>
             </a:r>
           </a:p>
         </p:txBody>

</xml_diff>